<commit_message>
wk13 slides - Added links to visualization tools
</commit_message>
<xml_diff>
--- a/week13/wk13_Slides.pptx
+++ b/week13/wk13_Slides.pptx
@@ -9468,7 +9468,7 @@
         </p:nvSpPr>
         <p:spPr>
           <a:xfrm>
-            <a:off x="1524000" y="1122363"/>
+            <a:off x="1595966" y="201542"/>
             <a:ext cx="9144000" cy="1654393"/>
           </a:xfrm>
         </p:spPr>
@@ -9516,8 +9516,8 @@
         </p:blipFill>
         <p:spPr bwMode="auto">
           <a:xfrm>
-            <a:off x="3435443" y="2875920"/>
-            <a:ext cx="5398083" cy="2947801"/>
+            <a:off x="4106334" y="1941052"/>
+            <a:ext cx="4401225" cy="2403434"/>
           </a:xfrm>
           <a:prstGeom prst="rect">
             <a:avLst/>
@@ -9534,6 +9534,124 @@
           </a:extLst>
         </p:spPr>
       </p:pic>
+      <p:sp>
+        <p:nvSpPr>
+          <p:cNvPr id="6" name="TextBox 5">
+            <a:extLst>
+              <a:ext uri="{FF2B5EF4-FFF2-40B4-BE49-F238E27FC236}">
+                <a16:creationId xmlns:a16="http://schemas.microsoft.com/office/drawing/2014/main" id="{B8FA4EAA-9286-4DB8-2B45-7A57214AF7E5}"/>
+              </a:ext>
+            </a:extLst>
+          </p:cNvPr>
+          <p:cNvSpPr txBox="1"/>
+          <p:nvPr/>
+        </p:nvSpPr>
+        <p:spPr>
+          <a:xfrm>
+            <a:off x="3217333" y="5437651"/>
+            <a:ext cx="6096000" cy="369332"/>
+          </a:xfrm>
+          <a:prstGeom prst="rect">
+            <a:avLst/>
+          </a:prstGeom>
+          <a:noFill/>
+        </p:spPr>
+        <p:txBody>
+          <a:bodyPr wrap="square">
+            <a:spAutoFit/>
+          </a:bodyPr>
+          <a:lstStyle/>
+          <a:p>
+            <a:pPr algn="ctr"/>
+            <a:r>
+              <a:rPr lang="en-US" dirty="0">
+                <a:hlinkClick r:id="rId3"/>
+              </a:rPr>
+              <a:t>https://visualgo.net/en/sorting</a:t>
+            </a:r>
+            <a:r>
+              <a:rPr lang="en-US" dirty="0"/>
+              <a:t> </a:t>
+            </a:r>
+          </a:p>
+        </p:txBody>
+      </p:sp>
+      <p:sp>
+        <p:nvSpPr>
+          <p:cNvPr id="8" name="TextBox 7">
+            <a:extLst>
+              <a:ext uri="{FF2B5EF4-FFF2-40B4-BE49-F238E27FC236}">
+                <a16:creationId xmlns:a16="http://schemas.microsoft.com/office/drawing/2014/main" id="{0912DFED-C05C-71C5-C17A-D8B81D10A376}"/>
+              </a:ext>
+            </a:extLst>
+          </p:cNvPr>
+          <p:cNvSpPr txBox="1"/>
+          <p:nvPr/>
+        </p:nvSpPr>
+        <p:spPr>
+          <a:xfrm>
+            <a:off x="2313516" y="5892100"/>
+            <a:ext cx="8500533" cy="369332"/>
+          </a:xfrm>
+          <a:prstGeom prst="rect">
+            <a:avLst/>
+          </a:prstGeom>
+          <a:noFill/>
+        </p:spPr>
+        <p:txBody>
+          <a:bodyPr wrap="square">
+            <a:spAutoFit/>
+          </a:bodyPr>
+          <a:lstStyle/>
+          <a:p>
+            <a:r>
+              <a:rPr lang="en-US" dirty="0">
+                <a:hlinkClick r:id="rId4"/>
+              </a:rPr>
+              <a:t>https://www.hackerearth.com/practice/algorithms/sorting/merge-sort/visualize/</a:t>
+            </a:r>
+            <a:r>
+              <a:rPr lang="en-US" dirty="0"/>
+              <a:t> </a:t>
+            </a:r>
+          </a:p>
+        </p:txBody>
+      </p:sp>
+      <p:sp>
+        <p:nvSpPr>
+          <p:cNvPr id="10" name="TextBox 9">
+            <a:extLst>
+              <a:ext uri="{FF2B5EF4-FFF2-40B4-BE49-F238E27FC236}">
+                <a16:creationId xmlns:a16="http://schemas.microsoft.com/office/drawing/2014/main" id="{7780DD34-F23D-0E8C-6CB5-8FC25C82B649}"/>
+              </a:ext>
+            </a:extLst>
+          </p:cNvPr>
+          <p:cNvSpPr txBox="1"/>
+          <p:nvPr/>
+        </p:nvSpPr>
+        <p:spPr>
+          <a:xfrm>
+            <a:off x="5198532" y="4983202"/>
+            <a:ext cx="2730500" cy="369332"/>
+          </a:xfrm>
+          <a:prstGeom prst="rect">
+            <a:avLst/>
+          </a:prstGeom>
+          <a:noFill/>
+        </p:spPr>
+        <p:txBody>
+          <a:bodyPr wrap="square" rtlCol="0">
+            <a:spAutoFit/>
+          </a:bodyPr>
+          <a:lstStyle/>
+          <a:p>
+            <a:r>
+              <a:rPr lang="en-US" b="1" dirty="0"/>
+              <a:t>Visualization Tools:</a:t>
+            </a:r>
+          </a:p>
+        </p:txBody>
+      </p:sp>
     </p:spTree>
     <p:extLst>
       <p:ext uri="{BB962C8B-B14F-4D97-AF65-F5344CB8AC3E}">

</xml_diff>